<commit_message>
docs: update the fleetfolio tour deck
</commit_message>
<xml_diff>
--- a/opsfolio-branding/marketing-assets/presentations/fleetfolio-tour.pptx
+++ b/opsfolio-branding/marketing-assets/presentations/fleetfolio-tour.pptx
@@ -5,7 +5,7 @@
     <p:sldMasterId id="2147483648" r:id="rId1"/>
   </p:sldMasterIdLst>
   <p:notesMasterIdLst>
-    <p:notesMasterId r:id="rId19"/>
+    <p:notesMasterId r:id="rId20"/>
   </p:notesMasterIdLst>
   <p:sldIdLst>
     <p:sldId id="256" r:id="rId2"/>
@@ -16,15 +16,16 @@
     <p:sldId id="261" r:id="rId7"/>
     <p:sldId id="262" r:id="rId8"/>
     <p:sldId id="263" r:id="rId9"/>
-    <p:sldId id="264" r:id="rId10"/>
-    <p:sldId id="265" r:id="rId11"/>
-    <p:sldId id="266" r:id="rId12"/>
-    <p:sldId id="267" r:id="rId13"/>
-    <p:sldId id="268" r:id="rId14"/>
-    <p:sldId id="269" r:id="rId15"/>
-    <p:sldId id="270" r:id="rId16"/>
-    <p:sldId id="271" r:id="rId17"/>
-    <p:sldId id="272" r:id="rId18"/>
+    <p:sldId id="273" r:id="rId10"/>
+    <p:sldId id="264" r:id="rId11"/>
+    <p:sldId id="265" r:id="rId12"/>
+    <p:sldId id="266" r:id="rId13"/>
+    <p:sldId id="267" r:id="rId14"/>
+    <p:sldId id="268" r:id="rId15"/>
+    <p:sldId id="269" r:id="rId16"/>
+    <p:sldId id="270" r:id="rId17"/>
+    <p:sldId id="271" r:id="rId18"/>
+    <p:sldId id="272" r:id="rId19"/>
   </p:sldIdLst>
   <p:sldSz cx="12192000" cy="6858000"/>
   <p:notesSz cx="6858000" cy="12192000"/>
@@ -959,6 +960,85 @@
 </p:notes>
 </file>
 
+<file path=ppt/notesSlides/notesSlide18.xml><?xml version="1.0" encoding="utf-8"?>
+<p:notes xmlns:a="http://schemas.openxmlformats.org/drawingml/2006/main" xmlns:r="http://schemas.openxmlformats.org/officeDocument/2006/relationships" xmlns:p="http://schemas.openxmlformats.org/presentationml/2006/main">
+  <p:cSld>
+    <p:spTree>
+      <p:nvGrpSpPr>
+        <p:cNvPr id="1" name=""/>
+        <p:cNvGrpSpPr/>
+        <p:nvPr/>
+      </p:nvGrpSpPr>
+      <p:grpSpPr>
+        <a:xfrm>
+          <a:off x="0" y="0"/>
+          <a:ext cx="0" cy="0"/>
+          <a:chOff x="0" y="0"/>
+          <a:chExt cx="0" cy="0"/>
+        </a:xfrm>
+      </p:grpSpPr>
+      <p:sp>
+        <p:nvSpPr>
+          <p:cNvPr id="2" name="Slide Image Placeholder 1"/>
+          <p:cNvSpPr>
+            <a:spLocks noGrp="1" noRot="1" noChangeAspect="1"/>
+          </p:cNvSpPr>
+          <p:nvPr>
+            <p:ph type="sldImg"/>
+          </p:nvPr>
+        </p:nvSpPr>
+        <p:spPr/>
+      </p:sp>
+      <p:sp>
+        <p:nvSpPr>
+          <p:cNvPr id="3" name="Notes Placeholder 2"/>
+          <p:cNvSpPr>
+            <a:spLocks noGrp="1"/>
+          </p:cNvSpPr>
+          <p:nvPr>
+            <p:ph type="body" idx="1"/>
+          </p:nvPr>
+        </p:nvSpPr>
+        <p:spPr/>
+        <p:txBody>
+          <a:bodyPr/>
+          <a:lstStyle/>
+          <a:p>
+            <a:endParaRPr lang="en-US" dirty="0"/>
+          </a:p>
+        </p:txBody>
+      </p:sp>
+      <p:sp>
+        <p:nvSpPr>
+          <p:cNvPr id="4" name="Slide Number Placeholder 3"/>
+          <p:cNvSpPr>
+            <a:spLocks noGrp="1"/>
+          </p:cNvSpPr>
+          <p:nvPr>
+            <p:ph type="sldNum" sz="quarter" idx="10"/>
+          </p:nvPr>
+        </p:nvSpPr>
+        <p:spPr/>
+        <p:txBody>
+          <a:bodyPr/>
+          <a:lstStyle/>
+          <a:p>
+            <a:fld id="{F7021451-1387-4CA6-816F-3879F97B5CBC}" type="slidenum">
+              <a:rPr lang="en-US"/>
+              <a:t>18</a:t>
+            </a:fld>
+            <a:endParaRPr lang="en-US"/>
+          </a:p>
+        </p:txBody>
+      </p:sp>
+    </p:spTree>
+  </p:cSld>
+  <p:clrMapOvr>
+    <a:masterClrMapping/>
+  </p:clrMapOvr>
+</p:notes>
+</file>
+
 <file path=ppt/notesSlides/notesSlide2.xml><?xml version="1.0" encoding="utf-8"?>
 <p:notes xmlns:a="http://schemas.openxmlformats.org/drawingml/2006/main" xmlns:r="http://schemas.openxmlformats.org/officeDocument/2006/relationships" xmlns:p="http://schemas.openxmlformats.org/presentationml/2006/main">
   <p:cSld>
@@ -1517,7 +1597,13 @@
   <p:cSld>
     <p:spTree>
       <p:nvGrpSpPr>
-        <p:cNvPr id="1" name=""/>
+        <p:cNvPr id="1" name="">
+          <a:extLst>
+            <a:ext uri="{FF2B5EF4-FFF2-40B4-BE49-F238E27FC236}">
+              <a16:creationId xmlns:a16="http://schemas.microsoft.com/office/drawing/2014/main" id="{41F4FDB9-C73F-8D99-14E6-90E5F63ED0BF}"/>
+            </a:ext>
+          </a:extLst>
+        </p:cNvPr>
         <p:cNvGrpSpPr/>
         <p:nvPr/>
       </p:nvGrpSpPr>
@@ -1531,7 +1617,13 @@
       </p:grpSpPr>
       <p:sp>
         <p:nvSpPr>
-          <p:cNvPr id="2" name="Slide Image Placeholder 1"/>
+          <p:cNvPr id="2" name="Slide Image Placeholder 1">
+            <a:extLst>
+              <a:ext uri="{FF2B5EF4-FFF2-40B4-BE49-F238E27FC236}">
+                <a16:creationId xmlns:a16="http://schemas.microsoft.com/office/drawing/2014/main" id="{9B92616E-7C46-DAB4-A089-6AAA68037982}"/>
+              </a:ext>
+            </a:extLst>
+          </p:cNvPr>
           <p:cNvSpPr>
             <a:spLocks noGrp="1" noRot="1" noChangeAspect="1"/>
           </p:cNvSpPr>
@@ -1543,7 +1635,13 @@
       </p:sp>
       <p:sp>
         <p:nvSpPr>
-          <p:cNvPr id="3" name="Notes Placeholder 2"/>
+          <p:cNvPr id="3" name="Notes Placeholder 2">
+            <a:extLst>
+              <a:ext uri="{FF2B5EF4-FFF2-40B4-BE49-F238E27FC236}">
+                <a16:creationId xmlns:a16="http://schemas.microsoft.com/office/drawing/2014/main" id="{0134777E-2B46-3F2D-CFD9-14D78737CA91}"/>
+              </a:ext>
+            </a:extLst>
+          </p:cNvPr>
           <p:cNvSpPr>
             <a:spLocks noGrp="1"/>
           </p:cNvSpPr>
@@ -1562,7 +1660,13 @@
       </p:sp>
       <p:sp>
         <p:nvSpPr>
-          <p:cNvPr id="4" name="Slide Number Placeholder 3"/>
+          <p:cNvPr id="4" name="Slide Number Placeholder 3">
+            <a:extLst>
+              <a:ext uri="{FF2B5EF4-FFF2-40B4-BE49-F238E27FC236}">
+                <a16:creationId xmlns:a16="http://schemas.microsoft.com/office/drawing/2014/main" id="{EC02099C-1B33-A205-C2D4-58F804A0B5B8}"/>
+              </a:ext>
+            </a:extLst>
+          </p:cNvPr>
           <p:cNvSpPr>
             <a:spLocks noGrp="1"/>
           </p:cNvSpPr>
@@ -1584,6 +1688,11 @@
         </p:txBody>
       </p:sp>
     </p:spTree>
+    <p:extLst>
+      <p:ext uri="{BB962C8B-B14F-4D97-AF65-F5344CB8AC3E}">
+        <p14:creationId xmlns:p14="http://schemas.microsoft.com/office/powerpoint/2010/main" val="1287977923"/>
+      </p:ext>
+    </p:extLst>
   </p:cSld>
   <p:clrMapOvr>
     <a:masterClrMapping/>
@@ -6901,6 +7010,981 @@
 <file path=ppt/slides/slide10.xml><?xml version="1.0" encoding="utf-8"?>
 <p:sld xmlns:a="http://schemas.openxmlformats.org/drawingml/2006/main" xmlns:r="http://schemas.openxmlformats.org/officeDocument/2006/relationships" xmlns:p="http://schemas.openxmlformats.org/presentationml/2006/main">
   <p:cSld>
+    <p:spTree>
+      <p:nvGrpSpPr>
+        <p:cNvPr id="1" name=""/>
+        <p:cNvGrpSpPr/>
+        <p:nvPr/>
+      </p:nvGrpSpPr>
+      <p:grpSpPr>
+        <a:xfrm>
+          <a:off x="0" y="0"/>
+          <a:ext cx="0" cy="0"/>
+          <a:chOff x="0" y="0"/>
+          <a:chExt cx="0" cy="0"/>
+        </a:xfrm>
+      </p:grpSpPr>
+      <p:sp>
+        <p:nvSpPr>
+          <p:cNvPr id="2" name="Shape 0"/>
+          <p:cNvSpPr/>
+          <p:nvPr/>
+        </p:nvSpPr>
+        <p:spPr>
+          <a:xfrm>
+            <a:off x="0" y="0"/>
+            <a:ext cx="4114800" cy="6858000"/>
+          </a:xfrm>
+          <a:prstGeom prst="rect">
+            <a:avLst/>
+          </a:prstGeom>
+          <a:solidFill>
+            <a:srgbClr val="0A2240"/>
+          </a:solidFill>
+          <a:ln w="12700">
+            <a:solidFill>
+              <a:srgbClr val="0A2240"/>
+            </a:solidFill>
+            <a:prstDash val="solid"/>
+          </a:ln>
+        </p:spPr>
+        <p:txBody>
+          <a:bodyPr/>
+          <a:lstStyle/>
+          <a:p>
+            <a:endParaRPr lang="en-US"/>
+          </a:p>
+        </p:txBody>
+      </p:sp>
+      <p:sp>
+        <p:nvSpPr>
+          <p:cNvPr id="3" name="Shape 1"/>
+          <p:cNvSpPr/>
+          <p:nvPr/>
+        </p:nvSpPr>
+        <p:spPr>
+          <a:xfrm>
+            <a:off x="457200" y="228600"/>
+            <a:ext cx="1554480" cy="256032"/>
+          </a:xfrm>
+          <a:prstGeom prst="rect">
+            <a:avLst/>
+          </a:prstGeom>
+          <a:solidFill>
+            <a:srgbClr val="0891B2"/>
+          </a:solidFill>
+          <a:ln w="12700">
+            <a:solidFill>
+              <a:srgbClr val="0891B2"/>
+            </a:solidFill>
+            <a:prstDash val="solid"/>
+          </a:ln>
+        </p:spPr>
+        <p:txBody>
+          <a:bodyPr/>
+          <a:lstStyle/>
+          <a:p>
+            <a:endParaRPr lang="en-US"/>
+          </a:p>
+        </p:txBody>
+      </p:sp>
+      <p:sp>
+        <p:nvSpPr>
+          <p:cNvPr id="4" name="Text 2"/>
+          <p:cNvSpPr/>
+          <p:nvPr/>
+        </p:nvSpPr>
+        <p:spPr>
+          <a:xfrm>
+            <a:off x="457200" y="228600"/>
+            <a:ext cx="1554480" cy="256032"/>
+          </a:xfrm>
+          <a:prstGeom prst="rect">
+            <a:avLst/>
+          </a:prstGeom>
+          <a:noFill/>
+        </p:spPr>
+        <p:txBody>
+          <a:bodyPr wrap="square" lIns="0" tIns="0" rIns="0" bIns="0" rtlCol="0" anchor="ctr"/>
+          <a:lstStyle/>
+          <a:p>
+            <a:pPr marL="0" indent="0" algn="ctr">
+              <a:buNone/>
+            </a:pPr>
+            <a:r>
+              <a:rPr lang="en-US" sz="900" b="1" kern="0" spc="100" dirty="0">
+                <a:solidFill>
+                  <a:srgbClr val="FFFFFF"/>
+                </a:solidFill>
+                <a:latin typeface="Calibri" pitchFamily="34" charset="0"/>
+                <a:ea typeface="Calibri" pitchFamily="34" charset="-122"/>
+                <a:cs typeface="Calibri" pitchFamily="34" charset="-120"/>
+              </a:rPr>
+              <a:t>POSTURE</a:t>
+            </a:r>
+            <a:endParaRPr lang="en-US" sz="900" dirty="0"/>
+          </a:p>
+        </p:txBody>
+      </p:sp>
+      <p:sp>
+        <p:nvSpPr>
+          <p:cNvPr id="5" name="Text 3"/>
+          <p:cNvSpPr/>
+          <p:nvPr/>
+        </p:nvSpPr>
+        <p:spPr>
+          <a:xfrm>
+            <a:off x="365760" y="548640"/>
+            <a:ext cx="3566160" cy="731520"/>
+          </a:xfrm>
+          <a:prstGeom prst="rect">
+            <a:avLst/>
+          </a:prstGeom>
+          <a:noFill/>
+        </p:spPr>
+        <p:txBody>
+          <a:bodyPr wrap="square" rtlCol="0" anchor="t"/>
+          <a:lstStyle/>
+          <a:p>
+            <a:pPr marL="0" indent="0">
+              <a:buNone/>
+            </a:pPr>
+            <a:r>
+              <a:rPr lang="en-US" sz="2600" b="1" dirty="0">
+                <a:solidFill>
+                  <a:srgbClr val="FFFFFF"/>
+                </a:solidFill>
+                <a:latin typeface="Calibri" pitchFamily="34" charset="0"/>
+                <a:ea typeface="Calibri" pitchFamily="34" charset="-122"/>
+                <a:cs typeface="Calibri" pitchFamily="34" charset="-120"/>
+              </a:rPr>
+              <a:t>Security Posture</a:t>
+            </a:r>
+            <a:endParaRPr lang="en-US" sz="2600" dirty="0"/>
+          </a:p>
+          <a:p>
+            <a:pPr marL="0" indent="0">
+              <a:buNone/>
+            </a:pPr>
+            <a:r>
+              <a:rPr lang="en-US" sz="2600" b="1" dirty="0">
+                <a:solidFill>
+                  <a:srgbClr val="FFFFFF"/>
+                </a:solidFill>
+                <a:latin typeface="Calibri" pitchFamily="34" charset="0"/>
+                <a:ea typeface="Calibri" pitchFamily="34" charset="-122"/>
+                <a:cs typeface="Calibri" pitchFamily="34" charset="-120"/>
+              </a:rPr>
+              <a:t>&amp; Config Management</a:t>
+            </a:r>
+            <a:endParaRPr lang="en-US" sz="2600" dirty="0"/>
+          </a:p>
+        </p:txBody>
+      </p:sp>
+      <p:sp>
+        <p:nvSpPr>
+          <p:cNvPr id="6" name="Text 4"/>
+          <p:cNvSpPr/>
+          <p:nvPr/>
+        </p:nvSpPr>
+        <p:spPr>
+          <a:xfrm>
+            <a:off x="365760" y="1325880"/>
+            <a:ext cx="3566160" cy="347472"/>
+          </a:xfrm>
+          <a:prstGeom prst="rect">
+            <a:avLst/>
+          </a:prstGeom>
+          <a:noFill/>
+        </p:spPr>
+        <p:txBody>
+          <a:bodyPr wrap="square" rtlCol="0" anchor="ctr"/>
+          <a:lstStyle/>
+          <a:p>
+            <a:pPr marL="0" indent="0">
+              <a:buNone/>
+            </a:pPr>
+            <a:r>
+              <a:rPr lang="en-US" sz="1200" i="1" dirty="0">
+                <a:solidFill>
+                  <a:srgbClr val="06B6D4"/>
+                </a:solidFill>
+                <a:latin typeface="Calibri" pitchFamily="34" charset="0"/>
+                <a:ea typeface="Calibri" pitchFamily="34" charset="-122"/>
+                <a:cs typeface="Calibri" pitchFamily="34" charset="-120"/>
+              </a:rPr>
+              <a:t>Policy-as-SQL: version-controlled, testable, drift-detecting.</a:t>
+            </a:r>
+            <a:endParaRPr lang="en-US" sz="1200" dirty="0"/>
+          </a:p>
+        </p:txBody>
+      </p:sp>
+      <p:sp>
+        <p:nvSpPr>
+          <p:cNvPr id="7" name="Text 5"/>
+          <p:cNvSpPr/>
+          <p:nvPr/>
+        </p:nvSpPr>
+        <p:spPr>
+          <a:xfrm>
+            <a:off x="365760" y="1737360"/>
+            <a:ext cx="3611880" cy="4480560"/>
+          </a:xfrm>
+          <a:prstGeom prst="rect">
+            <a:avLst/>
+          </a:prstGeom>
+          <a:noFill/>
+        </p:spPr>
+        <p:txBody>
+          <a:bodyPr wrap="square" rtlCol="0" anchor="t"/>
+          <a:lstStyle/>
+          <a:p>
+            <a:pPr marL="342900" indent="-342900">
+              <a:spcAft>
+                <a:spcPts val="600"/>
+              </a:spcAft>
+              <a:buSzPct val="100000"/>
+              <a:buChar char="•"/>
+            </a:pPr>
+            <a:r>
+              <a:rPr lang="en-US" sz="1250" dirty="0">
+                <a:solidFill>
+                  <a:srgbClr val="B0CEDF"/>
+                </a:solidFill>
+                <a:latin typeface="Calibri" pitchFamily="34" charset="0"/>
+                <a:ea typeface="Calibri" pitchFamily="34" charset="-122"/>
+                <a:cs typeface="Calibri" pitchFamily="34" charset="-120"/>
+              </a:rPr>
+              <a:t>Disk encryption, firewall status, OS version, patch level — all boolean SQL fields</a:t>
+            </a:r>
+            <a:endParaRPr lang="en-US" sz="1250" dirty="0"/>
+          </a:p>
+          <a:p>
+            <a:pPr marL="342900" indent="-342900">
+              <a:spcAft>
+                <a:spcPts val="600"/>
+              </a:spcAft>
+              <a:buSzPct val="100000"/>
+              <a:buChar char="•"/>
+            </a:pPr>
+            <a:r>
+              <a:rPr lang="en-US" sz="1250" dirty="0">
+                <a:solidFill>
+                  <a:srgbClr val="B0CEDF"/>
+                </a:solidFill>
+                <a:latin typeface="Calibri" pitchFamily="34" charset="0"/>
+                <a:ea typeface="Calibri" pitchFamily="34" charset="-122"/>
+                <a:cs typeface="Calibri" pitchFamily="34" charset="-120"/>
+              </a:rPr>
+              <a:t>Drift detection: devices that were compliant and are now not — with timestamps and audit trail</a:t>
+            </a:r>
+            <a:endParaRPr lang="en-US" sz="1250" dirty="0"/>
+          </a:p>
+          <a:p>
+            <a:pPr marL="342900" indent="-342900">
+              <a:spcAft>
+                <a:spcPts val="600"/>
+              </a:spcAft>
+              <a:buSzPct val="100000"/>
+              <a:buChar char="•"/>
+            </a:pPr>
+            <a:r>
+              <a:rPr lang="en-US" sz="1250" dirty="0">
+                <a:solidFill>
+                  <a:srgbClr val="B0CEDF"/>
+                </a:solidFill>
+                <a:latin typeface="Calibri" pitchFamily="34" charset="0"/>
+                <a:ea typeface="Calibri" pitchFamily="34" charset="-122"/>
+                <a:cs typeface="Calibri" pitchFamily="34" charset="-120"/>
+              </a:rPr>
+              <a:t>Before/after evidence snapshots for every posture change</a:t>
+            </a:r>
+            <a:endParaRPr lang="en-US" sz="1250" dirty="0"/>
+          </a:p>
+          <a:p>
+            <a:pPr marL="342900" indent="-342900">
+              <a:spcAft>
+                <a:spcPts val="600"/>
+              </a:spcAft>
+              <a:buSzPct val="100000"/>
+              <a:buChar char="•"/>
+            </a:pPr>
+            <a:r>
+              <a:rPr lang="en-US" sz="1250" dirty="0">
+                <a:solidFill>
+                  <a:srgbClr val="B0CEDF"/>
+                </a:solidFill>
+                <a:latin typeface="Calibri" pitchFamily="34" charset="0"/>
+                <a:ea typeface="Calibri" pitchFamily="34" charset="-122"/>
+                <a:cs typeface="Calibri" pitchFamily="34" charset="-120"/>
+              </a:rPr>
+              <a:t>Compliance control mapping built into each policy query (ISO 27001, SOC 2, NIST)</a:t>
+            </a:r>
+            <a:endParaRPr lang="en-US" sz="1250" dirty="0"/>
+          </a:p>
+          <a:p>
+            <a:pPr marL="342900" indent="-342900">
+              <a:spcAft>
+                <a:spcPts val="600"/>
+              </a:spcAft>
+              <a:buSzPct val="100000"/>
+              <a:buChar char="•"/>
+            </a:pPr>
+            <a:r>
+              <a:rPr lang="en-US" sz="1250" dirty="0">
+                <a:solidFill>
+                  <a:srgbClr val="B0CEDF"/>
+                </a:solidFill>
+                <a:latin typeface="Calibri" pitchFamily="34" charset="0"/>
+                <a:ea typeface="Calibri" pitchFamily="34" charset="-122"/>
+                <a:cs typeface="Calibri" pitchFamily="34" charset="-120"/>
+              </a:rPr>
+              <a:t>Alert on regression: when a device drops below baseline, a gap signal is immediately asserted</a:t>
+            </a:r>
+            <a:endParaRPr lang="en-US" sz="1250" dirty="0"/>
+          </a:p>
+        </p:txBody>
+      </p:sp>
+      <p:sp>
+        <p:nvSpPr>
+          <p:cNvPr id="8" name="Shape 6"/>
+          <p:cNvSpPr/>
+          <p:nvPr/>
+        </p:nvSpPr>
+        <p:spPr>
+          <a:xfrm>
+            <a:off x="228600" y="5760720"/>
+            <a:ext cx="1109472" cy="777240"/>
+          </a:xfrm>
+          <a:prstGeom prst="rect">
+            <a:avLst/>
+          </a:prstGeom>
+          <a:solidFill>
+            <a:srgbClr val="0C2B42"/>
+          </a:solidFill>
+          <a:ln w="12700">
+            <a:solidFill>
+              <a:srgbClr val="1A4060"/>
+            </a:solidFill>
+            <a:prstDash val="solid"/>
+          </a:ln>
+        </p:spPr>
+        <p:txBody>
+          <a:bodyPr/>
+          <a:lstStyle/>
+          <a:p>
+            <a:endParaRPr lang="en-US"/>
+          </a:p>
+        </p:txBody>
+      </p:sp>
+      <p:sp>
+        <p:nvSpPr>
+          <p:cNvPr id="9" name="Text 7"/>
+          <p:cNvSpPr/>
+          <p:nvPr/>
+        </p:nvSpPr>
+        <p:spPr>
+          <a:xfrm>
+            <a:off x="228600" y="5806440"/>
+            <a:ext cx="1109472" cy="347472"/>
+          </a:xfrm>
+          <a:prstGeom prst="rect">
+            <a:avLst/>
+          </a:prstGeom>
+          <a:noFill/>
+        </p:spPr>
+        <p:txBody>
+          <a:bodyPr wrap="square" lIns="0" tIns="0" rIns="0" bIns="0" rtlCol="0" anchor="ctr"/>
+          <a:lstStyle/>
+          <a:p>
+            <a:pPr marL="0" indent="0" algn="ctr">
+              <a:buNone/>
+            </a:pPr>
+            <a:r>
+              <a:rPr lang="en-US" sz="2200" b="1" dirty="0">
+                <a:solidFill>
+                  <a:srgbClr val="06B6D4"/>
+                </a:solidFill>
+                <a:latin typeface="Calibri" pitchFamily="34" charset="0"/>
+                <a:ea typeface="Calibri" pitchFamily="34" charset="-122"/>
+                <a:cs typeface="Calibri" pitchFamily="34" charset="-120"/>
+              </a:rPr>
+              <a:t>Drift</a:t>
+            </a:r>
+            <a:endParaRPr lang="en-US" sz="2200" dirty="0"/>
+          </a:p>
+        </p:txBody>
+      </p:sp>
+      <p:sp>
+        <p:nvSpPr>
+          <p:cNvPr id="10" name="Text 8"/>
+          <p:cNvSpPr/>
+          <p:nvPr/>
+        </p:nvSpPr>
+        <p:spPr>
+          <a:xfrm>
+            <a:off x="283464" y="6163056"/>
+            <a:ext cx="999744" cy="274320"/>
+          </a:xfrm>
+          <a:prstGeom prst="rect">
+            <a:avLst/>
+          </a:prstGeom>
+          <a:noFill/>
+        </p:spPr>
+        <p:txBody>
+          <a:bodyPr wrap="square" lIns="0" tIns="0" rIns="0" bIns="0" rtlCol="0" anchor="ctr"/>
+          <a:lstStyle/>
+          <a:p>
+            <a:pPr marL="0" indent="0" algn="ctr">
+              <a:buNone/>
+            </a:pPr>
+            <a:r>
+              <a:rPr lang="en-US" sz="900" dirty="0">
+                <a:solidFill>
+                  <a:srgbClr val="90A4AE"/>
+                </a:solidFill>
+                <a:latin typeface="Calibri" pitchFamily="34" charset="0"/>
+                <a:ea typeface="Calibri" pitchFamily="34" charset="-122"/>
+                <a:cs typeface="Calibri" pitchFamily="34" charset="-120"/>
+              </a:rPr>
+              <a:t>Auto-Detected</a:t>
+            </a:r>
+            <a:endParaRPr lang="en-US" sz="900" dirty="0"/>
+          </a:p>
+        </p:txBody>
+      </p:sp>
+      <p:sp>
+        <p:nvSpPr>
+          <p:cNvPr id="11" name="Shape 9"/>
+          <p:cNvSpPr/>
+          <p:nvPr/>
+        </p:nvSpPr>
+        <p:spPr>
+          <a:xfrm>
+            <a:off x="1447800" y="5760720"/>
+            <a:ext cx="1109472" cy="777240"/>
+          </a:xfrm>
+          <a:prstGeom prst="rect">
+            <a:avLst/>
+          </a:prstGeom>
+          <a:solidFill>
+            <a:srgbClr val="0C2B42"/>
+          </a:solidFill>
+          <a:ln w="12700">
+            <a:solidFill>
+              <a:srgbClr val="1A4060"/>
+            </a:solidFill>
+            <a:prstDash val="solid"/>
+          </a:ln>
+        </p:spPr>
+        <p:txBody>
+          <a:bodyPr/>
+          <a:lstStyle/>
+          <a:p>
+            <a:endParaRPr lang="en-US"/>
+          </a:p>
+        </p:txBody>
+      </p:sp>
+      <p:sp>
+        <p:nvSpPr>
+          <p:cNvPr id="12" name="Text 10"/>
+          <p:cNvSpPr/>
+          <p:nvPr/>
+        </p:nvSpPr>
+        <p:spPr>
+          <a:xfrm>
+            <a:off x="1447800" y="5806440"/>
+            <a:ext cx="1109472" cy="347472"/>
+          </a:xfrm>
+          <a:prstGeom prst="rect">
+            <a:avLst/>
+          </a:prstGeom>
+          <a:noFill/>
+        </p:spPr>
+        <p:txBody>
+          <a:bodyPr wrap="square" lIns="0" tIns="0" rIns="0" bIns="0" rtlCol="0" anchor="ctr"/>
+          <a:lstStyle/>
+          <a:p>
+            <a:pPr marL="0" indent="0" algn="ctr">
+              <a:buNone/>
+            </a:pPr>
+            <a:r>
+              <a:rPr lang="en-US" sz="2200" b="1" dirty="0">
+                <a:solidFill>
+                  <a:srgbClr val="06B6D4"/>
+                </a:solidFill>
+                <a:latin typeface="Calibri" pitchFamily="34" charset="0"/>
+                <a:ea typeface="Calibri" pitchFamily="34" charset="-122"/>
+                <a:cs typeface="Calibri" pitchFamily="34" charset="-120"/>
+              </a:rPr>
+              <a:t>Hash</a:t>
+            </a:r>
+            <a:endParaRPr lang="en-US" sz="2200" dirty="0"/>
+          </a:p>
+        </p:txBody>
+      </p:sp>
+      <p:sp>
+        <p:nvSpPr>
+          <p:cNvPr id="13" name="Text 11"/>
+          <p:cNvSpPr/>
+          <p:nvPr/>
+        </p:nvSpPr>
+        <p:spPr>
+          <a:xfrm>
+            <a:off x="1502664" y="6163056"/>
+            <a:ext cx="999744" cy="274320"/>
+          </a:xfrm>
+          <a:prstGeom prst="rect">
+            <a:avLst/>
+          </a:prstGeom>
+          <a:noFill/>
+        </p:spPr>
+        <p:txBody>
+          <a:bodyPr wrap="square" lIns="0" tIns="0" rIns="0" bIns="0" rtlCol="0" anchor="ctr"/>
+          <a:lstStyle/>
+          <a:p>
+            <a:pPr marL="0" indent="0" algn="ctr">
+              <a:buNone/>
+            </a:pPr>
+            <a:r>
+              <a:rPr lang="en-US" sz="900" dirty="0">
+                <a:solidFill>
+                  <a:srgbClr val="90A4AE"/>
+                </a:solidFill>
+                <a:latin typeface="Calibri" pitchFamily="34" charset="0"/>
+                <a:ea typeface="Calibri" pitchFamily="34" charset="-122"/>
+                <a:cs typeface="Calibri" pitchFamily="34" charset="-120"/>
+              </a:rPr>
+              <a:t>Proof of State</a:t>
+            </a:r>
+            <a:endParaRPr lang="en-US" sz="900" dirty="0"/>
+          </a:p>
+        </p:txBody>
+      </p:sp>
+      <p:sp>
+        <p:nvSpPr>
+          <p:cNvPr id="14" name="Shape 12"/>
+          <p:cNvSpPr/>
+          <p:nvPr/>
+        </p:nvSpPr>
+        <p:spPr>
+          <a:xfrm>
+            <a:off x="2667000" y="5760720"/>
+            <a:ext cx="1109472" cy="777240"/>
+          </a:xfrm>
+          <a:prstGeom prst="rect">
+            <a:avLst/>
+          </a:prstGeom>
+          <a:solidFill>
+            <a:srgbClr val="0C2B42"/>
+          </a:solidFill>
+          <a:ln w="12700">
+            <a:solidFill>
+              <a:srgbClr val="1A4060"/>
+            </a:solidFill>
+            <a:prstDash val="solid"/>
+          </a:ln>
+        </p:spPr>
+        <p:txBody>
+          <a:bodyPr/>
+          <a:lstStyle/>
+          <a:p>
+            <a:endParaRPr lang="en-US"/>
+          </a:p>
+        </p:txBody>
+      </p:sp>
+      <p:sp>
+        <p:nvSpPr>
+          <p:cNvPr id="15" name="Text 13"/>
+          <p:cNvSpPr/>
+          <p:nvPr/>
+        </p:nvSpPr>
+        <p:spPr>
+          <a:xfrm>
+            <a:off x="2667000" y="5806440"/>
+            <a:ext cx="1109472" cy="347472"/>
+          </a:xfrm>
+          <a:prstGeom prst="rect">
+            <a:avLst/>
+          </a:prstGeom>
+          <a:noFill/>
+        </p:spPr>
+        <p:txBody>
+          <a:bodyPr wrap="square" lIns="0" tIns="0" rIns="0" bIns="0" rtlCol="0" anchor="ctr"/>
+          <a:lstStyle/>
+          <a:p>
+            <a:pPr marL="0" indent="0" algn="ctr">
+              <a:buNone/>
+            </a:pPr>
+            <a:r>
+              <a:rPr lang="en-US" sz="2200" b="1" dirty="0">
+                <a:solidFill>
+                  <a:srgbClr val="06B6D4"/>
+                </a:solidFill>
+                <a:latin typeface="Calibri" pitchFamily="34" charset="0"/>
+                <a:ea typeface="Calibri" pitchFamily="34" charset="-122"/>
+                <a:cs typeface="Calibri" pitchFamily="34" charset="-120"/>
+              </a:rPr>
+              <a:t>Live</a:t>
+            </a:r>
+            <a:endParaRPr lang="en-US" sz="2200" dirty="0"/>
+          </a:p>
+        </p:txBody>
+      </p:sp>
+      <p:sp>
+        <p:nvSpPr>
+          <p:cNvPr id="16" name="Text 14"/>
+          <p:cNvSpPr/>
+          <p:nvPr/>
+        </p:nvSpPr>
+        <p:spPr>
+          <a:xfrm>
+            <a:off x="2721864" y="6163056"/>
+            <a:ext cx="999744" cy="274320"/>
+          </a:xfrm>
+          <a:prstGeom prst="rect">
+            <a:avLst/>
+          </a:prstGeom>
+          <a:noFill/>
+        </p:spPr>
+        <p:txBody>
+          <a:bodyPr wrap="square" lIns="0" tIns="0" rIns="0" bIns="0" rtlCol="0" anchor="ctr"/>
+          <a:lstStyle/>
+          <a:p>
+            <a:pPr marL="0" indent="0" algn="ctr">
+              <a:buNone/>
+            </a:pPr>
+            <a:r>
+              <a:rPr lang="en-US" sz="900" dirty="0">
+                <a:solidFill>
+                  <a:srgbClr val="90A4AE"/>
+                </a:solidFill>
+                <a:latin typeface="Calibri" pitchFamily="34" charset="0"/>
+                <a:ea typeface="Calibri" pitchFamily="34" charset="-122"/>
+                <a:cs typeface="Calibri" pitchFamily="34" charset="-120"/>
+              </a:rPr>
+              <a:t>Posture Baseline</a:t>
+            </a:r>
+            <a:endParaRPr lang="en-US" sz="900" dirty="0"/>
+          </a:p>
+        </p:txBody>
+      </p:sp>
+      <p:sp>
+        <p:nvSpPr>
+          <p:cNvPr id="17" name="Shape 15"/>
+          <p:cNvSpPr/>
+          <p:nvPr/>
+        </p:nvSpPr>
+        <p:spPr>
+          <a:xfrm>
+            <a:off x="4297680" y="502920"/>
+            <a:ext cx="7571232" cy="347472"/>
+          </a:xfrm>
+          <a:prstGeom prst="rect">
+            <a:avLst/>
+          </a:prstGeom>
+          <a:solidFill>
+            <a:srgbClr val="1E2D3D"/>
+          </a:solidFill>
+          <a:ln w="12700">
+            <a:solidFill>
+              <a:srgbClr val="1E2D3D"/>
+            </a:solidFill>
+            <a:prstDash val="solid"/>
+          </a:ln>
+        </p:spPr>
+        <p:txBody>
+          <a:bodyPr/>
+          <a:lstStyle/>
+          <a:p>
+            <a:endParaRPr lang="en-US"/>
+          </a:p>
+        </p:txBody>
+      </p:sp>
+      <p:sp>
+        <p:nvSpPr>
+          <p:cNvPr id="18" name="Shape 16"/>
+          <p:cNvSpPr/>
+          <p:nvPr/>
+        </p:nvSpPr>
+        <p:spPr>
+          <a:xfrm>
+            <a:off x="4402836" y="617220"/>
+            <a:ext cx="118872" cy="118872"/>
+          </a:xfrm>
+          <a:prstGeom prst="ellipse">
+            <a:avLst/>
+          </a:prstGeom>
+          <a:solidFill>
+            <a:srgbClr val="FF5F57"/>
+          </a:solidFill>
+          <a:ln w="12700">
+            <a:solidFill>
+              <a:srgbClr val="FF5F57"/>
+            </a:solidFill>
+            <a:prstDash val="solid"/>
+          </a:ln>
+        </p:spPr>
+        <p:txBody>
+          <a:bodyPr/>
+          <a:lstStyle/>
+          <a:p>
+            <a:endParaRPr lang="en-US"/>
+          </a:p>
+        </p:txBody>
+      </p:sp>
+      <p:sp>
+        <p:nvSpPr>
+          <p:cNvPr id="19" name="Shape 17"/>
+          <p:cNvSpPr/>
+          <p:nvPr/>
+        </p:nvSpPr>
+        <p:spPr>
+          <a:xfrm>
+            <a:off x="4567428" y="617220"/>
+            <a:ext cx="118872" cy="118872"/>
+          </a:xfrm>
+          <a:prstGeom prst="ellipse">
+            <a:avLst/>
+          </a:prstGeom>
+          <a:solidFill>
+            <a:srgbClr val="FFBD2E"/>
+          </a:solidFill>
+          <a:ln w="12700">
+            <a:solidFill>
+              <a:srgbClr val="FFBD2E"/>
+            </a:solidFill>
+            <a:prstDash val="solid"/>
+          </a:ln>
+        </p:spPr>
+        <p:txBody>
+          <a:bodyPr/>
+          <a:lstStyle/>
+          <a:p>
+            <a:endParaRPr lang="en-US"/>
+          </a:p>
+        </p:txBody>
+      </p:sp>
+      <p:sp>
+        <p:nvSpPr>
+          <p:cNvPr id="20" name="Shape 18"/>
+          <p:cNvSpPr/>
+          <p:nvPr/>
+        </p:nvSpPr>
+        <p:spPr>
+          <a:xfrm>
+            <a:off x="4732020" y="617220"/>
+            <a:ext cx="118872" cy="118872"/>
+          </a:xfrm>
+          <a:prstGeom prst="ellipse">
+            <a:avLst/>
+          </a:prstGeom>
+          <a:solidFill>
+            <a:srgbClr val="28C840"/>
+          </a:solidFill>
+          <a:ln w="12700">
+            <a:solidFill>
+              <a:srgbClr val="28C840"/>
+            </a:solidFill>
+            <a:prstDash val="solid"/>
+          </a:ln>
+        </p:spPr>
+        <p:txBody>
+          <a:bodyPr/>
+          <a:lstStyle/>
+          <a:p>
+            <a:endParaRPr lang="en-US"/>
+          </a:p>
+        </p:txBody>
+      </p:sp>
+      <p:sp>
+        <p:nvSpPr>
+          <p:cNvPr id="21" name="Shape 19"/>
+          <p:cNvSpPr/>
+          <p:nvPr/>
+        </p:nvSpPr>
+        <p:spPr>
+          <a:xfrm>
+            <a:off x="4974336" y="566928"/>
+            <a:ext cx="6748272" cy="219456"/>
+          </a:xfrm>
+          <a:prstGeom prst="rect">
+            <a:avLst/>
+          </a:prstGeom>
+          <a:solidFill>
+            <a:srgbClr val="263748"/>
+          </a:solidFill>
+          <a:ln w="12700">
+            <a:solidFill>
+              <a:srgbClr val="384F64"/>
+            </a:solidFill>
+            <a:prstDash val="solid"/>
+          </a:ln>
+        </p:spPr>
+        <p:txBody>
+          <a:bodyPr/>
+          <a:lstStyle/>
+          <a:p>
+            <a:endParaRPr lang="en-US"/>
+          </a:p>
+        </p:txBody>
+      </p:sp>
+      <p:sp>
+        <p:nvSpPr>
+          <p:cNvPr id="22" name="Text 20"/>
+          <p:cNvSpPr/>
+          <p:nvPr/>
+        </p:nvSpPr>
+        <p:spPr>
+          <a:xfrm>
+            <a:off x="5047488" y="566928"/>
+            <a:ext cx="6656832" cy="219456"/>
+          </a:xfrm>
+          <a:prstGeom prst="rect">
+            <a:avLst/>
+          </a:prstGeom>
+          <a:noFill/>
+        </p:spPr>
+        <p:txBody>
+          <a:bodyPr wrap="square" lIns="0" tIns="0" rIns="0" bIns="0" rtlCol="0" anchor="ctr"/>
+          <a:lstStyle/>
+          <a:p>
+            <a:r>
+              <a:rPr lang="en-US" sz="800" dirty="0" err="1">
+                <a:solidFill>
+                  <a:srgbClr val="90A4AE"/>
+                </a:solidFill>
+                <a:latin typeface="Consolas" pitchFamily="34" charset="0"/>
+                <a:ea typeface="Consolas" pitchFamily="34" charset="-122"/>
+                <a:cs typeface="Consolas" pitchFamily="34" charset="-120"/>
+              </a:rPr>
+              <a:t>fleetfolio.dev</a:t>
+            </a:r>
+            <a:r>
+              <a:rPr lang="en-US" sz="800" dirty="0">
+                <a:solidFill>
+                  <a:srgbClr val="90A4AE"/>
+                </a:solidFill>
+                <a:latin typeface="Consolas" pitchFamily="34" charset="0"/>
+                <a:ea typeface="Consolas" pitchFamily="34" charset="-122"/>
+                <a:cs typeface="Consolas" pitchFamily="34" charset="-120"/>
+              </a:rPr>
+              <a:t>/product/posture</a:t>
+            </a:r>
+            <a:endParaRPr lang="en-US" sz="800" dirty="0"/>
+          </a:p>
+        </p:txBody>
+      </p:sp>
+      <p:sp>
+        <p:nvSpPr>
+          <p:cNvPr id="29" name="Shape 27"/>
+          <p:cNvSpPr/>
+          <p:nvPr/>
+        </p:nvSpPr>
+        <p:spPr>
+          <a:xfrm>
+            <a:off x="0" y="6803136"/>
+            <a:ext cx="12188952" cy="54864"/>
+          </a:xfrm>
+          <a:prstGeom prst="rect">
+            <a:avLst/>
+          </a:prstGeom>
+          <a:solidFill>
+            <a:srgbClr val="0891B2"/>
+          </a:solidFill>
+          <a:ln w="12700">
+            <a:solidFill>
+              <a:srgbClr val="0891B2"/>
+            </a:solidFill>
+            <a:prstDash val="solid"/>
+          </a:ln>
+        </p:spPr>
+        <p:txBody>
+          <a:bodyPr/>
+          <a:lstStyle/>
+          <a:p>
+            <a:endParaRPr lang="en-US"/>
+          </a:p>
+        </p:txBody>
+      </p:sp>
+      <p:sp>
+        <p:nvSpPr>
+          <p:cNvPr id="30" name="Text 28"/>
+          <p:cNvSpPr/>
+          <p:nvPr/>
+        </p:nvSpPr>
+        <p:spPr>
+          <a:xfrm>
+            <a:off x="365760" y="6565392"/>
+            <a:ext cx="11457432" cy="201168"/>
+          </a:xfrm>
+          <a:prstGeom prst="rect">
+            <a:avLst/>
+          </a:prstGeom>
+          <a:noFill/>
+        </p:spPr>
+        <p:txBody>
+          <a:bodyPr wrap="square" rtlCol="0" anchor="ctr"/>
+          <a:lstStyle/>
+          <a:p>
+            <a:pPr marL="0" indent="0" algn="ctr">
+              <a:buNone/>
+            </a:pPr>
+            <a:r>
+              <a:rPr lang="en-US" sz="800" dirty="0">
+                <a:solidFill>
+                  <a:srgbClr val="90A4AE"/>
+                </a:solidFill>
+                <a:latin typeface="Calibri" pitchFamily="34" charset="0"/>
+                <a:ea typeface="Calibri" pitchFamily="34" charset="-122"/>
+                <a:cs typeface="Calibri" pitchFamily="34" charset="-120"/>
+              </a:rPr>
+              <a:t>fleetfolio.dev  ·  Confidential</a:t>
+            </a:r>
+            <a:endParaRPr lang="en-US" sz="800" dirty="0"/>
+          </a:p>
+        </p:txBody>
+      </p:sp>
+      <p:pic>
+        <p:nvPicPr>
+          <p:cNvPr id="32" name="Picture 31">
+            <a:extLst>
+              <a:ext uri="{FF2B5EF4-FFF2-40B4-BE49-F238E27FC236}">
+                <a16:creationId xmlns:a16="http://schemas.microsoft.com/office/drawing/2014/main" id="{C5D4D05C-454E-8E79-E14D-FA2C5844E350}"/>
+              </a:ext>
+            </a:extLst>
+          </p:cNvPr>
+          <p:cNvPicPr>
+            <a:picLocks noChangeAspect="1"/>
+          </p:cNvPicPr>
+          <p:nvPr/>
+        </p:nvPicPr>
+        <p:blipFill>
+          <a:blip r:embed="rId3"/>
+          <a:srcRect/>
+          <a:stretch/>
+        </p:blipFill>
+        <p:spPr>
+          <a:xfrm>
+            <a:off x="4335572" y="939215"/>
+            <a:ext cx="7494551" cy="5561395"/>
+          </a:xfrm>
+          <a:prstGeom prst="rect">
+            <a:avLst/>
+          </a:prstGeom>
+        </p:spPr>
+      </p:pic>
+    </p:spTree>
+  </p:cSld>
+  <p:clrMapOvr>
+    <a:masterClrMapping/>
+  </p:clrMapOvr>
+</p:sld>
+</file>
+
+<file path=ppt/slides/slide11.xml><?xml version="1.0" encoding="utf-8"?>
+<p:sld xmlns:a="http://schemas.openxmlformats.org/drawingml/2006/main" xmlns:r="http://schemas.openxmlformats.org/officeDocument/2006/relationships" xmlns:p="http://schemas.openxmlformats.org/presentationml/2006/main">
+  <p:cSld>
     <p:bg>
       <p:bgPr>
         <a:solidFill>
@@ -7867,7 +8951,7 @@
 </p:sld>
 </file>
 
-<file path=ppt/slides/slide11.xml><?xml version="1.0" encoding="utf-8"?>
+<file path=ppt/slides/slide12.xml><?xml version="1.0" encoding="utf-8"?>
 <p:sld xmlns:a="http://schemas.openxmlformats.org/drawingml/2006/main" xmlns:r="http://schemas.openxmlformats.org/officeDocument/2006/relationships" xmlns:p="http://schemas.openxmlformats.org/presentationml/2006/main">
   <p:cSld>
     <p:spTree>
@@ -8826,8 +9910,8 @@
         </p:blipFill>
         <p:spPr>
           <a:xfrm>
-            <a:off x="4320124" y="962451"/>
-            <a:ext cx="7517643" cy="5575508"/>
+            <a:off x="4320124" y="1247178"/>
+            <a:ext cx="7517643" cy="5006053"/>
           </a:xfrm>
           <a:prstGeom prst="rect">
             <a:avLst/>
@@ -8842,7 +9926,7 @@
 </p:sld>
 </file>
 
-<file path=ppt/slides/slide12.xml><?xml version="1.0" encoding="utf-8"?>
+<file path=ppt/slides/slide13.xml><?xml version="1.0" encoding="utf-8"?>
 <p:sld xmlns:a="http://schemas.openxmlformats.org/drawingml/2006/main" xmlns:r="http://schemas.openxmlformats.org/officeDocument/2006/relationships" xmlns:p="http://schemas.openxmlformats.org/presentationml/2006/main">
   <p:cSld>
     <p:bg>
@@ -10021,7 +11105,7 @@
 </p:sld>
 </file>
 
-<file path=ppt/slides/slide13.xml><?xml version="1.0" encoding="utf-8"?>
+<file path=ppt/slides/slide14.xml><?xml version="1.0" encoding="utf-8"?>
 <p:sld xmlns:a="http://schemas.openxmlformats.org/drawingml/2006/main" xmlns:r="http://schemas.openxmlformats.org/officeDocument/2006/relationships" xmlns:p="http://schemas.openxmlformats.org/presentationml/2006/main">
   <p:cSld>
     <p:bg>
@@ -11359,7 +12443,7 @@
 </p:sld>
 </file>
 
-<file path=ppt/slides/slide14.xml><?xml version="1.0" encoding="utf-8"?>
+<file path=ppt/slides/slide15.xml><?xml version="1.0" encoding="utf-8"?>
 <p:sld xmlns:a="http://schemas.openxmlformats.org/drawingml/2006/main" xmlns:r="http://schemas.openxmlformats.org/officeDocument/2006/relationships" xmlns:p="http://schemas.openxmlformats.org/presentationml/2006/main">
   <p:cSld>
     <p:bg>
@@ -12936,7 +14020,7 @@
 </p:sld>
 </file>
 
-<file path=ppt/slides/slide15.xml><?xml version="1.0" encoding="utf-8"?>
+<file path=ppt/slides/slide16.xml><?xml version="1.0" encoding="utf-8"?>
 <p:sld xmlns:a="http://schemas.openxmlformats.org/drawingml/2006/main" xmlns:r="http://schemas.openxmlformats.org/officeDocument/2006/relationships" xmlns:p="http://schemas.openxmlformats.org/presentationml/2006/main">
   <p:cSld>
     <p:bg>
@@ -14276,7 +15360,7 @@
 </p:sld>
 </file>
 
-<file path=ppt/slides/slide16.xml><?xml version="1.0" encoding="utf-8"?>
+<file path=ppt/slides/slide17.xml><?xml version="1.0" encoding="utf-8"?>
 <p:sld xmlns:a="http://schemas.openxmlformats.org/drawingml/2006/main" xmlns:r="http://schemas.openxmlformats.org/officeDocument/2006/relationships" xmlns:p="http://schemas.openxmlformats.org/presentationml/2006/main">
   <p:cSld>
     <p:bg>
@@ -15091,7 +16175,7 @@
 </p:sld>
 </file>
 
-<file path=ppt/slides/slide17.xml><?xml version="1.0" encoding="utf-8"?>
+<file path=ppt/slides/slide18.xml><?xml version="1.0" encoding="utf-8"?>
 <p:sld xmlns:a="http://schemas.openxmlformats.org/drawingml/2006/main" xmlns:r="http://schemas.openxmlformats.org/officeDocument/2006/relationships" xmlns:p="http://schemas.openxmlformats.org/presentationml/2006/main">
   <p:cSld>
     <p:bg>
@@ -24172,9 +25256,23 @@
 <file path=ppt/slides/slide9.xml><?xml version="1.0" encoding="utf-8"?>
 <p:sld xmlns:a="http://schemas.openxmlformats.org/drawingml/2006/main" xmlns:r="http://schemas.openxmlformats.org/officeDocument/2006/relationships" xmlns:p="http://schemas.openxmlformats.org/presentationml/2006/main">
   <p:cSld>
+    <p:bg>
+      <p:bgPr>
+        <a:solidFill>
+          <a:srgbClr val="FFFFFF"/>
+        </a:solidFill>
+        <a:effectLst/>
+      </p:bgPr>
+    </p:bg>
     <p:spTree>
       <p:nvGrpSpPr>
-        <p:cNvPr id="1" name=""/>
+        <p:cNvPr id="1" name="">
+          <a:extLst>
+            <a:ext uri="{FF2B5EF4-FFF2-40B4-BE49-F238E27FC236}">
+              <a16:creationId xmlns:a16="http://schemas.microsoft.com/office/drawing/2014/main" id="{053704F6-F056-DC2B-8E28-8BD6EADFCEE3}"/>
+            </a:ext>
+          </a:extLst>
+        </p:cNvPr>
         <p:cNvGrpSpPr/>
         <p:nvPr/>
       </p:nvGrpSpPr>
@@ -24188,46 +25286,20 @@
       </p:grpSpPr>
       <p:sp>
         <p:nvSpPr>
-          <p:cNvPr id="2" name="Shape 0"/>
-          <p:cNvSpPr/>
-          <p:nvPr/>
-        </p:nvSpPr>
-        <p:spPr>
-          <a:xfrm>
-            <a:off x="0" y="0"/>
-            <a:ext cx="4114800" cy="6858000"/>
-          </a:xfrm>
-          <a:prstGeom prst="rect">
-            <a:avLst/>
-          </a:prstGeom>
-          <a:solidFill>
-            <a:srgbClr val="0A2240"/>
-          </a:solidFill>
-          <a:ln w="12700">
-            <a:solidFill>
-              <a:srgbClr val="0A2240"/>
-            </a:solidFill>
-            <a:prstDash val="solid"/>
-          </a:ln>
-        </p:spPr>
-        <p:txBody>
-          <a:bodyPr/>
-          <a:lstStyle/>
-          <a:p>
-            <a:endParaRPr lang="en-US"/>
-          </a:p>
-        </p:txBody>
-      </p:sp>
-      <p:sp>
-        <p:nvSpPr>
-          <p:cNvPr id="3" name="Shape 1"/>
-          <p:cNvSpPr/>
-          <p:nvPr/>
-        </p:nvSpPr>
-        <p:spPr>
-          <a:xfrm>
-            <a:off x="457200" y="228600"/>
-            <a:ext cx="1554480" cy="256032"/>
+          <p:cNvPr id="28" name="Shape 26">
+            <a:extLst>
+              <a:ext uri="{FF2B5EF4-FFF2-40B4-BE49-F238E27FC236}">
+                <a16:creationId xmlns:a16="http://schemas.microsoft.com/office/drawing/2014/main" id="{0353CA3F-457F-19C1-58DA-6BEBD76AEF6B}"/>
+              </a:ext>
+            </a:extLst>
+          </p:cNvPr>
+          <p:cNvSpPr/>
+          <p:nvPr/>
+        </p:nvSpPr>
+        <p:spPr>
+          <a:xfrm>
+            <a:off x="0" y="6803136"/>
+            <a:ext cx="12188952" cy="54864"/>
           </a:xfrm>
           <a:prstGeom prst="rect">
             <a:avLst/>
@@ -24252,14 +25324,20 @@
       </p:sp>
       <p:sp>
         <p:nvSpPr>
-          <p:cNvPr id="4" name="Text 2"/>
-          <p:cNvSpPr/>
-          <p:nvPr/>
-        </p:nvSpPr>
-        <p:spPr>
-          <a:xfrm>
-            <a:off x="457200" y="228600"/>
-            <a:ext cx="1554480" cy="256032"/>
+          <p:cNvPr id="29" name="Text 27">
+            <a:extLst>
+              <a:ext uri="{FF2B5EF4-FFF2-40B4-BE49-F238E27FC236}">
+                <a16:creationId xmlns:a16="http://schemas.microsoft.com/office/drawing/2014/main" id="{D75F7DE2-A1A8-858A-5AC3-0A84B165AEB7}"/>
+              </a:ext>
+            </a:extLst>
+          </p:cNvPr>
+          <p:cNvSpPr/>
+          <p:nvPr/>
+        </p:nvSpPr>
+        <p:spPr>
+          <a:xfrm>
+            <a:off x="365760" y="6565392"/>
+            <a:ext cx="11457432" cy="201168"/>
           </a:xfrm>
           <a:prstGeom prst="rect">
             <a:avLst/>
@@ -24267,832 +25345,13 @@
           <a:noFill/>
         </p:spPr>
         <p:txBody>
-          <a:bodyPr wrap="square" lIns="0" tIns="0" rIns="0" bIns="0" rtlCol="0" anchor="ctr"/>
+          <a:bodyPr wrap="square" rtlCol="0" anchor="ctr"/>
           <a:lstStyle/>
           <a:p>
             <a:pPr marL="0" indent="0" algn="ctr">
               <a:buNone/>
             </a:pPr>
             <a:r>
-              <a:rPr lang="en-US" sz="900" b="1" kern="0" spc="100" dirty="0">
-                <a:solidFill>
-                  <a:srgbClr val="FFFFFF"/>
-                </a:solidFill>
-                <a:latin typeface="Calibri" pitchFamily="34" charset="0"/>
-                <a:ea typeface="Calibri" pitchFamily="34" charset="-122"/>
-                <a:cs typeface="Calibri" pitchFamily="34" charset="-120"/>
-              </a:rPr>
-              <a:t>POSTURE</a:t>
-            </a:r>
-            <a:endParaRPr lang="en-US" sz="900" dirty="0"/>
-          </a:p>
-        </p:txBody>
-      </p:sp>
-      <p:sp>
-        <p:nvSpPr>
-          <p:cNvPr id="5" name="Text 3"/>
-          <p:cNvSpPr/>
-          <p:nvPr/>
-        </p:nvSpPr>
-        <p:spPr>
-          <a:xfrm>
-            <a:off x="365760" y="548640"/>
-            <a:ext cx="3566160" cy="731520"/>
-          </a:xfrm>
-          <a:prstGeom prst="rect">
-            <a:avLst/>
-          </a:prstGeom>
-          <a:noFill/>
-        </p:spPr>
-        <p:txBody>
-          <a:bodyPr wrap="square" rtlCol="0" anchor="t"/>
-          <a:lstStyle/>
-          <a:p>
-            <a:pPr marL="0" indent="0">
-              <a:buNone/>
-            </a:pPr>
-            <a:r>
-              <a:rPr lang="en-US" sz="2600" b="1" dirty="0">
-                <a:solidFill>
-                  <a:srgbClr val="FFFFFF"/>
-                </a:solidFill>
-                <a:latin typeface="Calibri" pitchFamily="34" charset="0"/>
-                <a:ea typeface="Calibri" pitchFamily="34" charset="-122"/>
-                <a:cs typeface="Calibri" pitchFamily="34" charset="-120"/>
-              </a:rPr>
-              <a:t>Security Posture</a:t>
-            </a:r>
-            <a:endParaRPr lang="en-US" sz="2600" dirty="0"/>
-          </a:p>
-          <a:p>
-            <a:pPr marL="0" indent="0">
-              <a:buNone/>
-            </a:pPr>
-            <a:r>
-              <a:rPr lang="en-US" sz="2600" b="1" dirty="0">
-                <a:solidFill>
-                  <a:srgbClr val="FFFFFF"/>
-                </a:solidFill>
-                <a:latin typeface="Calibri" pitchFamily="34" charset="0"/>
-                <a:ea typeface="Calibri" pitchFamily="34" charset="-122"/>
-                <a:cs typeface="Calibri" pitchFamily="34" charset="-120"/>
-              </a:rPr>
-              <a:t>&amp; Config Management</a:t>
-            </a:r>
-            <a:endParaRPr lang="en-US" sz="2600" dirty="0"/>
-          </a:p>
-        </p:txBody>
-      </p:sp>
-      <p:sp>
-        <p:nvSpPr>
-          <p:cNvPr id="6" name="Text 4"/>
-          <p:cNvSpPr/>
-          <p:nvPr/>
-        </p:nvSpPr>
-        <p:spPr>
-          <a:xfrm>
-            <a:off x="365760" y="1325880"/>
-            <a:ext cx="3566160" cy="347472"/>
-          </a:xfrm>
-          <a:prstGeom prst="rect">
-            <a:avLst/>
-          </a:prstGeom>
-          <a:noFill/>
-        </p:spPr>
-        <p:txBody>
-          <a:bodyPr wrap="square" rtlCol="0" anchor="ctr"/>
-          <a:lstStyle/>
-          <a:p>
-            <a:pPr marL="0" indent="0">
-              <a:buNone/>
-            </a:pPr>
-            <a:r>
-              <a:rPr lang="en-US" sz="1200" i="1" dirty="0">
-                <a:solidFill>
-                  <a:srgbClr val="06B6D4"/>
-                </a:solidFill>
-                <a:latin typeface="Calibri" pitchFamily="34" charset="0"/>
-                <a:ea typeface="Calibri" pitchFamily="34" charset="-122"/>
-                <a:cs typeface="Calibri" pitchFamily="34" charset="-120"/>
-              </a:rPr>
-              <a:t>Policy-as-SQL: version-controlled, testable, drift-detecting.</a:t>
-            </a:r>
-            <a:endParaRPr lang="en-US" sz="1200" dirty="0"/>
-          </a:p>
-        </p:txBody>
-      </p:sp>
-      <p:sp>
-        <p:nvSpPr>
-          <p:cNvPr id="7" name="Text 5"/>
-          <p:cNvSpPr/>
-          <p:nvPr/>
-        </p:nvSpPr>
-        <p:spPr>
-          <a:xfrm>
-            <a:off x="365760" y="1737360"/>
-            <a:ext cx="3611880" cy="4480560"/>
-          </a:xfrm>
-          <a:prstGeom prst="rect">
-            <a:avLst/>
-          </a:prstGeom>
-          <a:noFill/>
-        </p:spPr>
-        <p:txBody>
-          <a:bodyPr wrap="square" rtlCol="0" anchor="t"/>
-          <a:lstStyle/>
-          <a:p>
-            <a:pPr marL="342900" indent="-342900">
-              <a:spcAft>
-                <a:spcPts val="600"/>
-              </a:spcAft>
-              <a:buSzPct val="100000"/>
-              <a:buChar char="•"/>
-            </a:pPr>
-            <a:r>
-              <a:rPr lang="en-US" sz="1250" dirty="0">
-                <a:solidFill>
-                  <a:srgbClr val="B0CEDF"/>
-                </a:solidFill>
-                <a:latin typeface="Calibri" pitchFamily="34" charset="0"/>
-                <a:ea typeface="Calibri" pitchFamily="34" charset="-122"/>
-                <a:cs typeface="Calibri" pitchFamily="34" charset="-120"/>
-              </a:rPr>
-              <a:t>Disk encryption, firewall status, OS version, patch level — all boolean SQL fields</a:t>
-            </a:r>
-            <a:endParaRPr lang="en-US" sz="1250" dirty="0"/>
-          </a:p>
-          <a:p>
-            <a:pPr marL="342900" indent="-342900">
-              <a:spcAft>
-                <a:spcPts val="600"/>
-              </a:spcAft>
-              <a:buSzPct val="100000"/>
-              <a:buChar char="•"/>
-            </a:pPr>
-            <a:r>
-              <a:rPr lang="en-US" sz="1250" dirty="0">
-                <a:solidFill>
-                  <a:srgbClr val="B0CEDF"/>
-                </a:solidFill>
-                <a:latin typeface="Calibri" pitchFamily="34" charset="0"/>
-                <a:ea typeface="Calibri" pitchFamily="34" charset="-122"/>
-                <a:cs typeface="Calibri" pitchFamily="34" charset="-120"/>
-              </a:rPr>
-              <a:t>Drift detection: devices that were compliant and are now not — with timestamps and audit trail</a:t>
-            </a:r>
-            <a:endParaRPr lang="en-US" sz="1250" dirty="0"/>
-          </a:p>
-          <a:p>
-            <a:pPr marL="342900" indent="-342900">
-              <a:spcAft>
-                <a:spcPts val="600"/>
-              </a:spcAft>
-              <a:buSzPct val="100000"/>
-              <a:buChar char="•"/>
-            </a:pPr>
-            <a:r>
-              <a:rPr lang="en-US" sz="1250" dirty="0">
-                <a:solidFill>
-                  <a:srgbClr val="B0CEDF"/>
-                </a:solidFill>
-                <a:latin typeface="Calibri" pitchFamily="34" charset="0"/>
-                <a:ea typeface="Calibri" pitchFamily="34" charset="-122"/>
-                <a:cs typeface="Calibri" pitchFamily="34" charset="-120"/>
-              </a:rPr>
-              <a:t>Before/after evidence snapshots for every posture change</a:t>
-            </a:r>
-            <a:endParaRPr lang="en-US" sz="1250" dirty="0"/>
-          </a:p>
-          <a:p>
-            <a:pPr marL="342900" indent="-342900">
-              <a:spcAft>
-                <a:spcPts val="600"/>
-              </a:spcAft>
-              <a:buSzPct val="100000"/>
-              <a:buChar char="•"/>
-            </a:pPr>
-            <a:r>
-              <a:rPr lang="en-US" sz="1250" dirty="0">
-                <a:solidFill>
-                  <a:srgbClr val="B0CEDF"/>
-                </a:solidFill>
-                <a:latin typeface="Calibri" pitchFamily="34" charset="0"/>
-                <a:ea typeface="Calibri" pitchFamily="34" charset="-122"/>
-                <a:cs typeface="Calibri" pitchFamily="34" charset="-120"/>
-              </a:rPr>
-              <a:t>Compliance control mapping built into each policy query (ISO 27001, SOC 2, NIST)</a:t>
-            </a:r>
-            <a:endParaRPr lang="en-US" sz="1250" dirty="0"/>
-          </a:p>
-          <a:p>
-            <a:pPr marL="342900" indent="-342900">
-              <a:spcAft>
-                <a:spcPts val="600"/>
-              </a:spcAft>
-              <a:buSzPct val="100000"/>
-              <a:buChar char="•"/>
-            </a:pPr>
-            <a:r>
-              <a:rPr lang="en-US" sz="1250" dirty="0">
-                <a:solidFill>
-                  <a:srgbClr val="B0CEDF"/>
-                </a:solidFill>
-                <a:latin typeface="Calibri" pitchFamily="34" charset="0"/>
-                <a:ea typeface="Calibri" pitchFamily="34" charset="-122"/>
-                <a:cs typeface="Calibri" pitchFamily="34" charset="-120"/>
-              </a:rPr>
-              <a:t>Alert on regression: when a device drops below baseline, a gap signal is immediately asserted</a:t>
-            </a:r>
-            <a:endParaRPr lang="en-US" sz="1250" dirty="0"/>
-          </a:p>
-        </p:txBody>
-      </p:sp>
-      <p:sp>
-        <p:nvSpPr>
-          <p:cNvPr id="8" name="Shape 6"/>
-          <p:cNvSpPr/>
-          <p:nvPr/>
-        </p:nvSpPr>
-        <p:spPr>
-          <a:xfrm>
-            <a:off x="228600" y="5760720"/>
-            <a:ext cx="1109472" cy="777240"/>
-          </a:xfrm>
-          <a:prstGeom prst="rect">
-            <a:avLst/>
-          </a:prstGeom>
-          <a:solidFill>
-            <a:srgbClr val="0C2B42"/>
-          </a:solidFill>
-          <a:ln w="12700">
-            <a:solidFill>
-              <a:srgbClr val="1A4060"/>
-            </a:solidFill>
-            <a:prstDash val="solid"/>
-          </a:ln>
-        </p:spPr>
-        <p:txBody>
-          <a:bodyPr/>
-          <a:lstStyle/>
-          <a:p>
-            <a:endParaRPr lang="en-US"/>
-          </a:p>
-        </p:txBody>
-      </p:sp>
-      <p:sp>
-        <p:nvSpPr>
-          <p:cNvPr id="9" name="Text 7"/>
-          <p:cNvSpPr/>
-          <p:nvPr/>
-        </p:nvSpPr>
-        <p:spPr>
-          <a:xfrm>
-            <a:off x="228600" y="5806440"/>
-            <a:ext cx="1109472" cy="347472"/>
-          </a:xfrm>
-          <a:prstGeom prst="rect">
-            <a:avLst/>
-          </a:prstGeom>
-          <a:noFill/>
-        </p:spPr>
-        <p:txBody>
-          <a:bodyPr wrap="square" lIns="0" tIns="0" rIns="0" bIns="0" rtlCol="0" anchor="ctr"/>
-          <a:lstStyle/>
-          <a:p>
-            <a:pPr marL="0" indent="0" algn="ctr">
-              <a:buNone/>
-            </a:pPr>
-            <a:r>
-              <a:rPr lang="en-US" sz="2200" b="1" dirty="0">
-                <a:solidFill>
-                  <a:srgbClr val="06B6D4"/>
-                </a:solidFill>
-                <a:latin typeface="Calibri" pitchFamily="34" charset="0"/>
-                <a:ea typeface="Calibri" pitchFamily="34" charset="-122"/>
-                <a:cs typeface="Calibri" pitchFamily="34" charset="-120"/>
-              </a:rPr>
-              <a:t>Drift</a:t>
-            </a:r>
-            <a:endParaRPr lang="en-US" sz="2200" dirty="0"/>
-          </a:p>
-        </p:txBody>
-      </p:sp>
-      <p:sp>
-        <p:nvSpPr>
-          <p:cNvPr id="10" name="Text 8"/>
-          <p:cNvSpPr/>
-          <p:nvPr/>
-        </p:nvSpPr>
-        <p:spPr>
-          <a:xfrm>
-            <a:off x="283464" y="6163056"/>
-            <a:ext cx="999744" cy="274320"/>
-          </a:xfrm>
-          <a:prstGeom prst="rect">
-            <a:avLst/>
-          </a:prstGeom>
-          <a:noFill/>
-        </p:spPr>
-        <p:txBody>
-          <a:bodyPr wrap="square" lIns="0" tIns="0" rIns="0" bIns="0" rtlCol="0" anchor="ctr"/>
-          <a:lstStyle/>
-          <a:p>
-            <a:pPr marL="0" indent="0" algn="ctr">
-              <a:buNone/>
-            </a:pPr>
-            <a:r>
-              <a:rPr lang="en-US" sz="900" dirty="0">
-                <a:solidFill>
-                  <a:srgbClr val="90A4AE"/>
-                </a:solidFill>
-                <a:latin typeface="Calibri" pitchFamily="34" charset="0"/>
-                <a:ea typeface="Calibri" pitchFamily="34" charset="-122"/>
-                <a:cs typeface="Calibri" pitchFamily="34" charset="-120"/>
-              </a:rPr>
-              <a:t>Auto-Detected</a:t>
-            </a:r>
-            <a:endParaRPr lang="en-US" sz="900" dirty="0"/>
-          </a:p>
-        </p:txBody>
-      </p:sp>
-      <p:sp>
-        <p:nvSpPr>
-          <p:cNvPr id="11" name="Shape 9"/>
-          <p:cNvSpPr/>
-          <p:nvPr/>
-        </p:nvSpPr>
-        <p:spPr>
-          <a:xfrm>
-            <a:off x="1447800" y="5760720"/>
-            <a:ext cx="1109472" cy="777240"/>
-          </a:xfrm>
-          <a:prstGeom prst="rect">
-            <a:avLst/>
-          </a:prstGeom>
-          <a:solidFill>
-            <a:srgbClr val="0C2B42"/>
-          </a:solidFill>
-          <a:ln w="12700">
-            <a:solidFill>
-              <a:srgbClr val="1A4060"/>
-            </a:solidFill>
-            <a:prstDash val="solid"/>
-          </a:ln>
-        </p:spPr>
-        <p:txBody>
-          <a:bodyPr/>
-          <a:lstStyle/>
-          <a:p>
-            <a:endParaRPr lang="en-US"/>
-          </a:p>
-        </p:txBody>
-      </p:sp>
-      <p:sp>
-        <p:nvSpPr>
-          <p:cNvPr id="12" name="Text 10"/>
-          <p:cNvSpPr/>
-          <p:nvPr/>
-        </p:nvSpPr>
-        <p:spPr>
-          <a:xfrm>
-            <a:off x="1447800" y="5806440"/>
-            <a:ext cx="1109472" cy="347472"/>
-          </a:xfrm>
-          <a:prstGeom prst="rect">
-            <a:avLst/>
-          </a:prstGeom>
-          <a:noFill/>
-        </p:spPr>
-        <p:txBody>
-          <a:bodyPr wrap="square" lIns="0" tIns="0" rIns="0" bIns="0" rtlCol="0" anchor="ctr"/>
-          <a:lstStyle/>
-          <a:p>
-            <a:pPr marL="0" indent="0" algn="ctr">
-              <a:buNone/>
-            </a:pPr>
-            <a:r>
-              <a:rPr lang="en-US" sz="2200" b="1" dirty="0">
-                <a:solidFill>
-                  <a:srgbClr val="06B6D4"/>
-                </a:solidFill>
-                <a:latin typeface="Calibri" pitchFamily="34" charset="0"/>
-                <a:ea typeface="Calibri" pitchFamily="34" charset="-122"/>
-                <a:cs typeface="Calibri" pitchFamily="34" charset="-120"/>
-              </a:rPr>
-              <a:t>Hash</a:t>
-            </a:r>
-            <a:endParaRPr lang="en-US" sz="2200" dirty="0"/>
-          </a:p>
-        </p:txBody>
-      </p:sp>
-      <p:sp>
-        <p:nvSpPr>
-          <p:cNvPr id="13" name="Text 11"/>
-          <p:cNvSpPr/>
-          <p:nvPr/>
-        </p:nvSpPr>
-        <p:spPr>
-          <a:xfrm>
-            <a:off x="1502664" y="6163056"/>
-            <a:ext cx="999744" cy="274320"/>
-          </a:xfrm>
-          <a:prstGeom prst="rect">
-            <a:avLst/>
-          </a:prstGeom>
-          <a:noFill/>
-        </p:spPr>
-        <p:txBody>
-          <a:bodyPr wrap="square" lIns="0" tIns="0" rIns="0" bIns="0" rtlCol="0" anchor="ctr"/>
-          <a:lstStyle/>
-          <a:p>
-            <a:pPr marL="0" indent="0" algn="ctr">
-              <a:buNone/>
-            </a:pPr>
-            <a:r>
-              <a:rPr lang="en-US" sz="900" dirty="0">
-                <a:solidFill>
-                  <a:srgbClr val="90A4AE"/>
-                </a:solidFill>
-                <a:latin typeface="Calibri" pitchFamily="34" charset="0"/>
-                <a:ea typeface="Calibri" pitchFamily="34" charset="-122"/>
-                <a:cs typeface="Calibri" pitchFamily="34" charset="-120"/>
-              </a:rPr>
-              <a:t>Proof of State</a:t>
-            </a:r>
-            <a:endParaRPr lang="en-US" sz="900" dirty="0"/>
-          </a:p>
-        </p:txBody>
-      </p:sp>
-      <p:sp>
-        <p:nvSpPr>
-          <p:cNvPr id="14" name="Shape 12"/>
-          <p:cNvSpPr/>
-          <p:nvPr/>
-        </p:nvSpPr>
-        <p:spPr>
-          <a:xfrm>
-            <a:off x="2667000" y="5760720"/>
-            <a:ext cx="1109472" cy="777240"/>
-          </a:xfrm>
-          <a:prstGeom prst="rect">
-            <a:avLst/>
-          </a:prstGeom>
-          <a:solidFill>
-            <a:srgbClr val="0C2B42"/>
-          </a:solidFill>
-          <a:ln w="12700">
-            <a:solidFill>
-              <a:srgbClr val="1A4060"/>
-            </a:solidFill>
-            <a:prstDash val="solid"/>
-          </a:ln>
-        </p:spPr>
-        <p:txBody>
-          <a:bodyPr/>
-          <a:lstStyle/>
-          <a:p>
-            <a:endParaRPr lang="en-US"/>
-          </a:p>
-        </p:txBody>
-      </p:sp>
-      <p:sp>
-        <p:nvSpPr>
-          <p:cNvPr id="15" name="Text 13"/>
-          <p:cNvSpPr/>
-          <p:nvPr/>
-        </p:nvSpPr>
-        <p:spPr>
-          <a:xfrm>
-            <a:off x="2667000" y="5806440"/>
-            <a:ext cx="1109472" cy="347472"/>
-          </a:xfrm>
-          <a:prstGeom prst="rect">
-            <a:avLst/>
-          </a:prstGeom>
-          <a:noFill/>
-        </p:spPr>
-        <p:txBody>
-          <a:bodyPr wrap="square" lIns="0" tIns="0" rIns="0" bIns="0" rtlCol="0" anchor="ctr"/>
-          <a:lstStyle/>
-          <a:p>
-            <a:pPr marL="0" indent="0" algn="ctr">
-              <a:buNone/>
-            </a:pPr>
-            <a:r>
-              <a:rPr lang="en-US" sz="2200" b="1" dirty="0">
-                <a:solidFill>
-                  <a:srgbClr val="06B6D4"/>
-                </a:solidFill>
-                <a:latin typeface="Calibri" pitchFamily="34" charset="0"/>
-                <a:ea typeface="Calibri" pitchFamily="34" charset="-122"/>
-                <a:cs typeface="Calibri" pitchFamily="34" charset="-120"/>
-              </a:rPr>
-              <a:t>Live</a:t>
-            </a:r>
-            <a:endParaRPr lang="en-US" sz="2200" dirty="0"/>
-          </a:p>
-        </p:txBody>
-      </p:sp>
-      <p:sp>
-        <p:nvSpPr>
-          <p:cNvPr id="16" name="Text 14"/>
-          <p:cNvSpPr/>
-          <p:nvPr/>
-        </p:nvSpPr>
-        <p:spPr>
-          <a:xfrm>
-            <a:off x="2721864" y="6163056"/>
-            <a:ext cx="999744" cy="274320"/>
-          </a:xfrm>
-          <a:prstGeom prst="rect">
-            <a:avLst/>
-          </a:prstGeom>
-          <a:noFill/>
-        </p:spPr>
-        <p:txBody>
-          <a:bodyPr wrap="square" lIns="0" tIns="0" rIns="0" bIns="0" rtlCol="0" anchor="ctr"/>
-          <a:lstStyle/>
-          <a:p>
-            <a:pPr marL="0" indent="0" algn="ctr">
-              <a:buNone/>
-            </a:pPr>
-            <a:r>
-              <a:rPr lang="en-US" sz="900" dirty="0">
-                <a:solidFill>
-                  <a:srgbClr val="90A4AE"/>
-                </a:solidFill>
-                <a:latin typeface="Calibri" pitchFamily="34" charset="0"/>
-                <a:ea typeface="Calibri" pitchFamily="34" charset="-122"/>
-                <a:cs typeface="Calibri" pitchFamily="34" charset="-120"/>
-              </a:rPr>
-              <a:t>Posture Baseline</a:t>
-            </a:r>
-            <a:endParaRPr lang="en-US" sz="900" dirty="0"/>
-          </a:p>
-        </p:txBody>
-      </p:sp>
-      <p:sp>
-        <p:nvSpPr>
-          <p:cNvPr id="17" name="Shape 15"/>
-          <p:cNvSpPr/>
-          <p:nvPr/>
-        </p:nvSpPr>
-        <p:spPr>
-          <a:xfrm>
-            <a:off x="4297680" y="502920"/>
-            <a:ext cx="7571232" cy="347472"/>
-          </a:xfrm>
-          <a:prstGeom prst="rect">
-            <a:avLst/>
-          </a:prstGeom>
-          <a:solidFill>
-            <a:srgbClr val="1E2D3D"/>
-          </a:solidFill>
-          <a:ln w="12700">
-            <a:solidFill>
-              <a:srgbClr val="1E2D3D"/>
-            </a:solidFill>
-            <a:prstDash val="solid"/>
-          </a:ln>
-        </p:spPr>
-        <p:txBody>
-          <a:bodyPr/>
-          <a:lstStyle/>
-          <a:p>
-            <a:endParaRPr lang="en-US"/>
-          </a:p>
-        </p:txBody>
-      </p:sp>
-      <p:sp>
-        <p:nvSpPr>
-          <p:cNvPr id="18" name="Shape 16"/>
-          <p:cNvSpPr/>
-          <p:nvPr/>
-        </p:nvSpPr>
-        <p:spPr>
-          <a:xfrm>
-            <a:off x="4402836" y="617220"/>
-            <a:ext cx="118872" cy="118872"/>
-          </a:xfrm>
-          <a:prstGeom prst="ellipse">
-            <a:avLst/>
-          </a:prstGeom>
-          <a:solidFill>
-            <a:srgbClr val="FF5F57"/>
-          </a:solidFill>
-          <a:ln w="12700">
-            <a:solidFill>
-              <a:srgbClr val="FF5F57"/>
-            </a:solidFill>
-            <a:prstDash val="solid"/>
-          </a:ln>
-        </p:spPr>
-        <p:txBody>
-          <a:bodyPr/>
-          <a:lstStyle/>
-          <a:p>
-            <a:endParaRPr lang="en-US"/>
-          </a:p>
-        </p:txBody>
-      </p:sp>
-      <p:sp>
-        <p:nvSpPr>
-          <p:cNvPr id="19" name="Shape 17"/>
-          <p:cNvSpPr/>
-          <p:nvPr/>
-        </p:nvSpPr>
-        <p:spPr>
-          <a:xfrm>
-            <a:off x="4567428" y="617220"/>
-            <a:ext cx="118872" cy="118872"/>
-          </a:xfrm>
-          <a:prstGeom prst="ellipse">
-            <a:avLst/>
-          </a:prstGeom>
-          <a:solidFill>
-            <a:srgbClr val="FFBD2E"/>
-          </a:solidFill>
-          <a:ln w="12700">
-            <a:solidFill>
-              <a:srgbClr val="FFBD2E"/>
-            </a:solidFill>
-            <a:prstDash val="solid"/>
-          </a:ln>
-        </p:spPr>
-        <p:txBody>
-          <a:bodyPr/>
-          <a:lstStyle/>
-          <a:p>
-            <a:endParaRPr lang="en-US"/>
-          </a:p>
-        </p:txBody>
-      </p:sp>
-      <p:sp>
-        <p:nvSpPr>
-          <p:cNvPr id="20" name="Shape 18"/>
-          <p:cNvSpPr/>
-          <p:nvPr/>
-        </p:nvSpPr>
-        <p:spPr>
-          <a:xfrm>
-            <a:off x="4732020" y="617220"/>
-            <a:ext cx="118872" cy="118872"/>
-          </a:xfrm>
-          <a:prstGeom prst="ellipse">
-            <a:avLst/>
-          </a:prstGeom>
-          <a:solidFill>
-            <a:srgbClr val="28C840"/>
-          </a:solidFill>
-          <a:ln w="12700">
-            <a:solidFill>
-              <a:srgbClr val="28C840"/>
-            </a:solidFill>
-            <a:prstDash val="solid"/>
-          </a:ln>
-        </p:spPr>
-        <p:txBody>
-          <a:bodyPr/>
-          <a:lstStyle/>
-          <a:p>
-            <a:endParaRPr lang="en-US"/>
-          </a:p>
-        </p:txBody>
-      </p:sp>
-      <p:sp>
-        <p:nvSpPr>
-          <p:cNvPr id="21" name="Shape 19"/>
-          <p:cNvSpPr/>
-          <p:nvPr/>
-        </p:nvSpPr>
-        <p:spPr>
-          <a:xfrm>
-            <a:off x="4974336" y="566928"/>
-            <a:ext cx="6748272" cy="219456"/>
-          </a:xfrm>
-          <a:prstGeom prst="rect">
-            <a:avLst/>
-          </a:prstGeom>
-          <a:solidFill>
-            <a:srgbClr val="263748"/>
-          </a:solidFill>
-          <a:ln w="12700">
-            <a:solidFill>
-              <a:srgbClr val="384F64"/>
-            </a:solidFill>
-            <a:prstDash val="solid"/>
-          </a:ln>
-        </p:spPr>
-        <p:txBody>
-          <a:bodyPr/>
-          <a:lstStyle/>
-          <a:p>
-            <a:endParaRPr lang="en-US"/>
-          </a:p>
-        </p:txBody>
-      </p:sp>
-      <p:sp>
-        <p:nvSpPr>
-          <p:cNvPr id="22" name="Text 20"/>
-          <p:cNvSpPr/>
-          <p:nvPr/>
-        </p:nvSpPr>
-        <p:spPr>
-          <a:xfrm>
-            <a:off x="5047488" y="566928"/>
-            <a:ext cx="6656832" cy="219456"/>
-          </a:xfrm>
-          <a:prstGeom prst="rect">
-            <a:avLst/>
-          </a:prstGeom>
-          <a:noFill/>
-        </p:spPr>
-        <p:txBody>
-          <a:bodyPr wrap="square" lIns="0" tIns="0" rIns="0" bIns="0" rtlCol="0" anchor="ctr"/>
-          <a:lstStyle/>
-          <a:p>
-            <a:r>
-              <a:rPr lang="en-US" sz="800" dirty="0" err="1">
-                <a:solidFill>
-                  <a:srgbClr val="90A4AE"/>
-                </a:solidFill>
-                <a:latin typeface="Consolas" pitchFamily="34" charset="0"/>
-                <a:ea typeface="Consolas" pitchFamily="34" charset="-122"/>
-                <a:cs typeface="Consolas" pitchFamily="34" charset="-120"/>
-              </a:rPr>
-              <a:t>fleetfolio.dev</a:t>
-            </a:r>
-            <a:r>
-              <a:rPr lang="en-US" sz="800" dirty="0">
-                <a:solidFill>
-                  <a:srgbClr val="90A4AE"/>
-                </a:solidFill>
-                <a:latin typeface="Consolas" pitchFamily="34" charset="0"/>
-                <a:ea typeface="Consolas" pitchFamily="34" charset="-122"/>
-                <a:cs typeface="Consolas" pitchFamily="34" charset="-120"/>
-              </a:rPr>
-              <a:t>/product/posture</a:t>
-            </a:r>
-            <a:endParaRPr lang="en-US" sz="800" dirty="0"/>
-          </a:p>
-        </p:txBody>
-      </p:sp>
-      <p:sp>
-        <p:nvSpPr>
-          <p:cNvPr id="29" name="Shape 27"/>
-          <p:cNvSpPr/>
-          <p:nvPr/>
-        </p:nvSpPr>
-        <p:spPr>
-          <a:xfrm>
-            <a:off x="0" y="6803136"/>
-            <a:ext cx="12188952" cy="54864"/>
-          </a:xfrm>
-          <a:prstGeom prst="rect">
-            <a:avLst/>
-          </a:prstGeom>
-          <a:solidFill>
-            <a:srgbClr val="0891B2"/>
-          </a:solidFill>
-          <a:ln w="12700">
-            <a:solidFill>
-              <a:srgbClr val="0891B2"/>
-            </a:solidFill>
-            <a:prstDash val="solid"/>
-          </a:ln>
-        </p:spPr>
-        <p:txBody>
-          <a:bodyPr/>
-          <a:lstStyle/>
-          <a:p>
-            <a:endParaRPr lang="en-US"/>
-          </a:p>
-        </p:txBody>
-      </p:sp>
-      <p:sp>
-        <p:nvSpPr>
-          <p:cNvPr id="30" name="Text 28"/>
-          <p:cNvSpPr/>
-          <p:nvPr/>
-        </p:nvSpPr>
-        <p:spPr>
-          <a:xfrm>
-            <a:off x="365760" y="6565392"/>
-            <a:ext cx="11457432" cy="201168"/>
-          </a:xfrm>
-          <a:prstGeom prst="rect">
-            <a:avLst/>
-          </a:prstGeom>
-          <a:noFill/>
-        </p:spPr>
-        <p:txBody>
-          <a:bodyPr wrap="square" rtlCol="0" anchor="ctr"/>
-          <a:lstStyle/>
-          <a:p>
-            <a:pPr marL="0" indent="0" algn="ctr">
-              <a:buNone/>
-            </a:pPr>
-            <a:r>
               <a:rPr lang="en-US" sz="800" dirty="0">
                 <a:solidFill>
                   <a:srgbClr val="90A4AE"/>
@@ -25109,10 +25368,10 @@
       </p:sp>
       <p:pic>
         <p:nvPicPr>
-          <p:cNvPr id="32" name="Picture 31">
+          <p:cNvPr id="23" name="Picture 22">
             <a:extLst>
               <a:ext uri="{FF2B5EF4-FFF2-40B4-BE49-F238E27FC236}">
-                <a16:creationId xmlns:a16="http://schemas.microsoft.com/office/drawing/2014/main" id="{C5D4D05C-454E-8E79-E14D-FA2C5844E350}"/>
+                <a16:creationId xmlns:a16="http://schemas.microsoft.com/office/drawing/2014/main" id="{8F8CBF20-8374-3A59-A8BD-4AABD686E657}"/>
               </a:ext>
             </a:extLst>
           </p:cNvPr>
@@ -25128,8 +25387,8 @@
         </p:blipFill>
         <p:spPr>
           <a:xfrm>
-            <a:off x="4324575" y="957145"/>
-            <a:ext cx="7498615" cy="5561395"/>
+            <a:off x="13138" y="0"/>
+            <a:ext cx="12165724" cy="6857999"/>
           </a:xfrm>
           <a:prstGeom prst="rect">
             <a:avLst/>
@@ -25137,6 +25396,11 @@
         </p:spPr>
       </p:pic>
     </p:spTree>
+    <p:extLst>
+      <p:ext uri="{BB962C8B-B14F-4D97-AF65-F5344CB8AC3E}">
+        <p14:creationId xmlns:p14="http://schemas.microsoft.com/office/powerpoint/2010/main" val="3159897634"/>
+      </p:ext>
+    </p:extLst>
   </p:cSld>
   <p:clrMapOvr>
     <a:masterClrMapping/>

</xml_diff>